<commit_message>
Product intro deck, capture tooling, and share/deploy docs
Co-Authored-By: Claude Fable 5 <noreply@anthropic.com>
</commit_message>
<xml_diff>
--- a/slides/ISO_Product_Intro.pptx
+++ b/slides/ISO_Product_Intro.pptx
@@ -2050,7 +2050,7 @@
                 <a:ea typeface="Calibri" pitchFamily="34" charset="-122"/>
                 <a:cs typeface="Calibri" pitchFamily="34" charset="-120"/>
               </a:rPr>
-              <a:t>the interactive prototype runs in any browser — phone-sized, no install</a:t>
+              <a:t>pjeon18.github.io/iso-prototype — runs in any browser, no install</a:t>
             </a:r>
             <a:endParaRPr lang="en-US" sz="1200" dirty="0"/>
           </a:p>
@@ -2378,8 +2378,8 @@
         </p:nvSpPr>
         <p:spPr>
           <a:xfrm>
-            <a:off x="685800" y="1600200"/>
-            <a:ext cx="5577840" cy="4023360"/>
+            <a:off x="685800" y="1783080"/>
+            <a:ext cx="5577840" cy="4206240"/>
           </a:xfrm>
           <a:prstGeom prst="rect">
             <a:avLst/>
@@ -2393,13 +2393,13 @@
           <a:p>
             <a:pPr marL="177800" indent="-177800">
               <a:spcAft>
-                <a:spcPts val="1000"/>
+                <a:spcPts val="1500"/>
               </a:spcAft>
               <a:buSzPct val="100000"/>
               <a:buChar char="•"/>
             </a:pPr>
             <a:r>
-              <a:rPr lang="en-US" sz="1700" dirty="0">
+              <a:rPr lang="en-US" sz="1750" dirty="0">
                 <a:solidFill>
                   <a:srgbClr val="5A3418"/>
                 </a:solidFill>
@@ -2409,18 +2409,18 @@
               </a:rPr>
               <a:t>Swipe economics reward infinite options: more matches, more boosts, more time in-app.</a:t>
             </a:r>
-            <a:endParaRPr lang="en-US" sz="1700" dirty="0"/>
+            <a:endParaRPr lang="en-US" sz="1750" dirty="0"/>
           </a:p>
           <a:p>
             <a:pPr marL="177800" indent="-177800">
               <a:spcAft>
-                <a:spcPts val="1000"/>
+                <a:spcPts val="1500"/>
               </a:spcAft>
               <a:buSzPct val="100000"/>
               <a:buChar char="•"/>
             </a:pPr>
             <a:r>
-              <a:rPr lang="en-US" sz="1700" dirty="0">
+              <a:rPr lang="en-US" sz="1750" dirty="0">
                 <a:solidFill>
                   <a:srgbClr val="5A3418"/>
                 </a:solidFill>
@@ -2430,18 +2430,18 @@
               </a:rPr>
               <a:t>Users end up managing a roster of lukewarm “talking stages” — a part-time job nobody signed up for.</a:t>
             </a:r>
-            <a:endParaRPr lang="en-US" sz="1700" dirty="0"/>
+            <a:endParaRPr lang="en-US" sz="1750" dirty="0"/>
           </a:p>
           <a:p>
             <a:pPr marL="177800" indent="-177800">
               <a:spcAft>
-                <a:spcPts val="1000"/>
+                <a:spcPts val="1500"/>
               </a:spcAft>
               <a:buSzPct val="100000"/>
               <a:buChar char="•"/>
             </a:pPr>
             <a:r>
-              <a:rPr lang="en-US" sz="1700" dirty="0">
+              <a:rPr lang="en-US" sz="1750" dirty="0">
                 <a:solidFill>
                   <a:srgbClr val="5A3418"/>
                 </a:solidFill>
@@ -2451,7 +2451,7 @@
               </a:rPr>
               <a:t>Ghosting is normalized. Everyone feels disposable. Burnout drives people off the apps entirely.</a:t>
             </a:r>
-            <a:endParaRPr lang="en-US" sz="1700" dirty="0"/>
+            <a:endParaRPr lang="en-US" sz="1750" dirty="0"/>
           </a:p>
           <a:p>
             <a:pPr marL="177800" indent="-177800">
@@ -2459,7 +2459,7 @@
               <a:buChar char="•"/>
             </a:pPr>
             <a:r>
-              <a:rPr lang="en-US" sz="1700" dirty="0">
+              <a:rPr lang="en-US" sz="1750" dirty="0">
                 <a:solidFill>
                   <a:srgbClr val="5A3418"/>
                 </a:solidFill>
@@ -2469,7 +2469,7 @@
               </a:rPr>
               <a:t>The incumbent business model can't fix this — optionality is the revenue.</a:t>
             </a:r>
-            <a:endParaRPr lang="en-US" sz="1700" dirty="0"/>
+            <a:endParaRPr lang="en-US" sz="1750" dirty="0"/>
           </a:p>
         </p:txBody>
       </p:sp>
@@ -2836,7 +2836,7 @@
             <a:r>
               <a:rPr lang="en-US" sz="950" dirty="0">
                 <a:solidFill>
-                  <a:srgbClr val="A98F70"/>
+                  <a:srgbClr val="8A7460"/>
                 </a:solidFill>
                 <a:latin typeface="Calibri" pitchFamily="34" charset="0"/>
                 <a:ea typeface="Calibri" pitchFamily="34" charset="-122"/>
@@ -2888,8 +2888,8 @@
         </p:nvSpPr>
         <p:spPr>
           <a:xfrm>
-            <a:off x="685800" y="1051560"/>
-            <a:ext cx="6675120" cy="731520"/>
+            <a:off x="685800" y="914400"/>
+            <a:ext cx="7863840" cy="685800"/>
           </a:xfrm>
           <a:prstGeom prst="rect">
             <a:avLst/>
@@ -2905,7 +2905,7 @@
               <a:buNone/>
             </a:pPr>
             <a:r>
-              <a:rPr lang="en-US" sz="4000" b="1" dirty="0">
+              <a:rPr lang="en-US" sz="3600" b="1" dirty="0">
                 <a:solidFill>
                   <a:srgbClr val="3A2410"/>
                 </a:solidFill>
@@ -2915,7 +2915,7 @@
               </a:rPr>
               <a:t>One conversation at a time.</a:t>
             </a:r>
-            <a:endParaRPr lang="en-US" sz="4000" dirty="0"/>
+            <a:endParaRPr lang="en-US" sz="3600" dirty="0"/>
           </a:p>
         </p:txBody>
       </p:sp>
@@ -2928,7 +2928,7 @@
         <p:spPr>
           <a:xfrm>
             <a:off x="685800" y="1783080"/>
-            <a:ext cx="6675120" cy="731520"/>
+            <a:ext cx="7863840" cy="685800"/>
           </a:xfrm>
           <a:prstGeom prst="rect">
             <a:avLst/>
@@ -2944,7 +2944,7 @@
               <a:buNone/>
             </a:pPr>
             <a:r>
-              <a:rPr lang="en-US" sz="4000" b="1" dirty="0">
+              <a:rPr lang="en-US" sz="3600" b="1" dirty="0">
                 <a:solidFill>
                   <a:srgbClr val="FF8000"/>
                 </a:solidFill>
@@ -2954,7 +2954,7 @@
               </a:rPr>
               <a:t>Enforced.</a:t>
             </a:r>
-            <a:endParaRPr lang="en-US" sz="4000" dirty="0"/>
+            <a:endParaRPr lang="en-US" sz="3600" dirty="0"/>
           </a:p>
         </p:txBody>
       </p:sp>
@@ -2981,7 +2981,7 @@
           <a:p>
             <a:pPr marL="177800" indent="-177800">
               <a:spcAft>
-                <a:spcPts val="1000"/>
+                <a:spcPts val="1500"/>
               </a:spcAft>
               <a:buSzPct val="100000"/>
               <a:buChar char="•"/>
@@ -3002,7 +3002,7 @@
           <a:p>
             <a:pPr marL="177800" indent="-177800">
               <a:spcAft>
-                <a:spcPts val="1000"/>
+                <a:spcPts val="1500"/>
               </a:spcAft>
               <a:buSzPct val="100000"/>
               <a:buChar char="•"/>
@@ -3023,7 +3023,7 @@
           <a:p>
             <a:pPr marL="177800" indent="-177800">
               <a:spcAft>
-                <a:spcPts val="1000"/>
+                <a:spcPts val="1500"/>
               </a:spcAft>
               <a:buSzPct val="100000"/>
               <a:buChar char="•"/>
@@ -3044,7 +3044,7 @@
           <a:p>
             <a:pPr marL="177800" indent="-177800">
               <a:spcAft>
-                <a:spcPts val="1000"/>
+                <a:spcPts val="1500"/>
               </a:spcAft>
               <a:buSzPct val="100000"/>
               <a:buChar char="•"/>
@@ -4535,7 +4535,7 @@
           <a:p>
             <a:pPr marL="177800" indent="-177800">
               <a:spcAft>
-                <a:spcPts val="1000"/>
+                <a:spcPts val="1500"/>
               </a:spcAft>
               <a:buSzPct val="100000"/>
               <a:buChar char="•"/>
@@ -4556,7 +4556,7 @@
           <a:p>
             <a:pPr marL="177800" indent="-177800">
               <a:spcAft>
-                <a:spcPts val="1000"/>
+                <a:spcPts val="1500"/>
               </a:spcAft>
               <a:buSzPct val="100000"/>
               <a:buChar char="•"/>
@@ -4577,7 +4577,7 @@
           <a:p>
             <a:pPr marL="177800" indent="-177800">
               <a:spcAft>
-                <a:spcPts val="1000"/>
+                <a:spcPts val="1500"/>
               </a:spcAft>
               <a:buSzPct val="100000"/>
               <a:buChar char="•"/>
@@ -4598,7 +4598,7 @@
           <a:p>
             <a:pPr marL="177800" indent="-177800">
               <a:spcAft>
-                <a:spcPts val="1000"/>
+                <a:spcPts val="1500"/>
               </a:spcAft>
               <a:buSzPct val="100000"/>
               <a:buChar char="•"/>
@@ -4712,7 +4712,7 @@
           <a:p>
             <a:pPr marL="177800" indent="-177800">
               <a:spcAft>
-                <a:spcPts val="1000"/>
+                <a:spcPts val="1500"/>
               </a:spcAft>
               <a:buSzPct val="100000"/>
               <a:buChar char="•"/>
@@ -4733,7 +4733,7 @@
           <a:p>
             <a:pPr marL="177800" indent="-177800">
               <a:spcAft>
-                <a:spcPts val="1000"/>
+                <a:spcPts val="1500"/>
               </a:spcAft>
               <a:buSzPct val="100000"/>
               <a:buChar char="•"/>
@@ -4754,7 +4754,7 @@
           <a:p>
             <a:pPr marL="177800" indent="-177800">
               <a:spcAft>
-                <a:spcPts val="1000"/>
+                <a:spcPts val="1500"/>
               </a:spcAft>
               <a:buSzPct val="100000"/>
               <a:buChar char="•"/>
@@ -5889,7 +5889,7 @@
         <p:spPr>
           <a:xfrm>
             <a:off x="713232" y="3383280"/>
-            <a:ext cx="6400800" cy="3017520"/>
+            <a:ext cx="6720840" cy="3108960"/>
           </a:xfrm>
           <a:prstGeom prst="rect">
             <a:avLst/>
@@ -5903,7 +5903,7 @@
           <a:p>
             <a:pPr marL="177800" indent="-177800">
               <a:spcAft>
-                <a:spcPts val="1000"/>
+                <a:spcPts val="1500"/>
               </a:spcAft>
               <a:buSzPct val="100000"/>
               <a:buChar char="•"/>
@@ -5924,7 +5924,7 @@
           <a:p>
             <a:pPr marL="177800" indent="-177800">
               <a:spcAft>
-                <a:spcPts val="1000"/>
+                <a:spcPts val="1500"/>
               </a:spcAft>
               <a:buSzPct val="100000"/>
               <a:buChar char="•"/>
@@ -5945,7 +5945,7 @@
           <a:p>
             <a:pPr marL="177800" indent="-177800">
               <a:spcAft>
-                <a:spcPts val="1000"/>
+                <a:spcPts val="1500"/>
               </a:spcAft>
               <a:buSzPct val="100000"/>
               <a:buChar char="•"/>
@@ -5973,12 +5973,12 @@
         </p:nvSpPr>
         <p:spPr>
           <a:xfrm>
-            <a:off x="7772400" y="777240"/>
-            <a:ext cx="2492932" cy="5394960"/>
+            <a:off x="7818120" y="1508760"/>
+            <a:ext cx="1943642" cy="4206240"/>
           </a:xfrm>
           <a:prstGeom prst="roundRect">
             <a:avLst>
-              <a:gd name="adj" fmla="val 3301"/>
+              <a:gd name="adj" fmla="val 4234"/>
             </a:avLst>
           </a:prstGeom>
           <a:solidFill>
@@ -6015,8 +6015,8 @@
         </p:blipFill>
         <p:spPr>
           <a:xfrm>
-            <a:off x="7813548" y="818388"/>
-            <a:ext cx="2410636" cy="5312664"/>
+            <a:off x="7859268" y="1549908"/>
+            <a:ext cx="1861346" cy="4123944"/>
           </a:xfrm>
           <a:prstGeom prst="rect">
             <a:avLst/>
@@ -6031,12 +6031,12 @@
         </p:nvSpPr>
         <p:spPr>
           <a:xfrm>
-            <a:off x="10104120" y="777240"/>
-            <a:ext cx="2492932" cy="5394960"/>
+            <a:off x="9921240" y="1508760"/>
+            <a:ext cx="1943642" cy="4206240"/>
           </a:xfrm>
           <a:prstGeom prst="roundRect">
             <a:avLst>
-              <a:gd name="adj" fmla="val 3301"/>
+              <a:gd name="adj" fmla="val 4234"/>
             </a:avLst>
           </a:prstGeom>
           <a:solidFill>
@@ -6073,8 +6073,8 @@
         </p:blipFill>
         <p:spPr>
           <a:xfrm>
-            <a:off x="10145268" y="818388"/>
-            <a:ext cx="2410636" cy="5312664"/>
+            <a:off x="9962388" y="1549908"/>
+            <a:ext cx="1861346" cy="4123944"/>
           </a:xfrm>
           <a:prstGeom prst="rect">
             <a:avLst/>

</xml_diff>